<commit_message>
[dyad] Limiter à 5 références injectées dans la zone PowerPoint - wrote 1 file(s) + extra files edited outside of Dyad
</commit_message>
<xml_diff>
--- a/server/template.pptx
+++ b/server/template.pptx
@@ -3786,7 +3786,9 @@
       <p:sp>
         <p:nvSpPr>
           <p:cNvPr id="22" name="Freeform 22"/>
-          <p:cNvSpPr/>
+          <p:cNvSpPr>
+            <a:spLocks noGrp="1" noRot="1" noMove="1" noResize="1" noEditPoints="1" noAdjustHandles="1" noChangeArrowheads="1" noChangeShapeType="1"/>
+          </p:cNvSpPr>
           <p:nvPr/>
         </p:nvSpPr>
         <p:spPr>
@@ -5352,31 +5354,36 @@
       </p:sp>
       <p:sp>
         <p:nvSpPr>
-          <p:cNvPr id="34" name="Titre et contenu">
+          <p:cNvPr id="47" name="references_box">
             <a:extLst>
               <a:ext uri="{FF2B5EF4-FFF2-40B4-BE49-F238E27FC236}">
-                <a16:creationId xmlns:a16="http://schemas.microsoft.com/office/drawing/2014/main" id="{4CEFF9B1-86CE-62F3-CCFA-8FAC5184409D}"/>
+                <a16:creationId xmlns:a16="http://schemas.microsoft.com/office/drawing/2014/main" id="{6BB0EE3B-167B-95AA-D26F-E1D564CE7022}"/>
               </a:ext>
             </a:extLst>
           </p:cNvPr>
-          <p:cNvSpPr>
-            <a:spLocks noGrp="1"/>
-          </p:cNvSpPr>
-          <p:nvPr>
-            <p:ph type="subTitle" idx="1"/>
-          </p:nvPr>
+          <p:cNvSpPr txBox="1"/>
+          <p:nvPr/>
         </p:nvSpPr>
         <p:spPr>
           <a:xfrm>
-            <a:off x="3249868" y="5960514"/>
-            <a:ext cx="4127257" cy="4598988"/>
+            <a:off x="3195893" y="6202080"/>
+            <a:ext cx="4181232" cy="215444"/>
           </a:xfrm>
+          <a:prstGeom prst="rect">
+            <a:avLst/>
+          </a:prstGeom>
+          <a:noFill/>
         </p:spPr>
         <p:txBody>
-          <a:bodyPr/>
-          <a:lstStyle/>
-          <a:p>
-            <a:endParaRPr lang="fr-FR" dirty="0"/>
+          <a:bodyPr wrap="square" rtlCol="0">
+            <a:spAutoFit/>
+          </a:bodyPr>
+          <a:lstStyle/>
+          <a:p>
+            <a:r>
+              <a:rPr lang="fr-FR" sz="800" dirty="0"/>
+              <a:t>Références ici</a:t>
+            </a:r>
           </a:p>
         </p:txBody>
       </p:sp>

</xml_diff>

<commit_message>
[dyad] Ajout d'une fonction utilitaire pour tester l'enrichissement PowerPoint avec des données mock - wrote 1 file(s) + extra files edited outside of Dyad
</commit_message>
<xml_diff>
--- a/server/template.pptx
+++ b/server/template.pptx
@@ -5354,10 +5354,10 @@
       </p:sp>
       <p:sp>
         <p:nvSpPr>
-          <p:cNvPr id="47" name="references_box">
+          <p:cNvPr id="48" name="reference_1">
             <a:extLst>
               <a:ext uri="{FF2B5EF4-FFF2-40B4-BE49-F238E27FC236}">
-                <a16:creationId xmlns:a16="http://schemas.microsoft.com/office/drawing/2014/main" id="{6BB0EE3B-167B-95AA-D26F-E1D564CE7022}"/>
+                <a16:creationId xmlns:a16="http://schemas.microsoft.com/office/drawing/2014/main" id="{5C04E65F-AA9B-0AE9-2461-920FC3F903B2}"/>
               </a:ext>
             </a:extLst>
           </p:cNvPr>
@@ -5366,24 +5366,1079 @@
         </p:nvSpPr>
         <p:spPr>
           <a:xfrm>
-            <a:off x="3195893" y="6202080"/>
-            <a:ext cx="4181232" cy="215444"/>
+            <a:off x="3195893" y="5956300"/>
+            <a:ext cx="2200697" cy="914481"/>
           </a:xfrm>
           <a:prstGeom prst="rect">
             <a:avLst/>
           </a:prstGeom>
-          <a:noFill/>
         </p:spPr>
         <p:txBody>
-          <a:bodyPr wrap="square" rtlCol="0">
+          <a:bodyPr wrap="square" lIns="0" tIns="0" rIns="0" bIns="0" rtlCol="0" anchor="t">
             <a:spAutoFit/>
           </a:bodyPr>
           <a:lstStyle/>
           <a:p>
-            <a:r>
-              <a:rPr lang="fr-FR" sz="800" dirty="0"/>
-              <a:t>Références ici</a:t>
-            </a:r>
+            <a:pPr algn="l">
+              <a:lnSpc>
+                <a:spcPts val="1400"/>
+              </a:lnSpc>
+            </a:pPr>
+            <a:r>
+              <a:rPr lang="en-US" sz="1000" b="1" spc="-3" dirty="0">
+                <a:solidFill>
+                  <a:srgbClr val="1D1E3C"/>
+                </a:solidFill>
+                <a:latin typeface="Century Gothic Paneuropean Bold"/>
+                <a:ea typeface="Century Gothic Paneuropean Bold"/>
+                <a:cs typeface="Century Gothic Paneuropean Bold"/>
+                <a:sym typeface="Century Gothic Paneuropean Bold"/>
+              </a:rPr>
+              <a:t>{{REF_RESIDENCE}}</a:t>
+            </a:r>
+          </a:p>
+          <a:p>
+            <a:pPr marL="0" lvl="0" indent="0" algn="l">
+              <a:lnSpc>
+                <a:spcPts val="1400"/>
+              </a:lnSpc>
+              <a:spcBef>
+                <a:spcPct val="0"/>
+              </a:spcBef>
+            </a:pPr>
+            <a:r>
+              <a:rPr lang="en-US" sz="1000" u="none" strike="noStrike" spc="-3" dirty="0">
+                <a:solidFill>
+                  <a:srgbClr val="1D1E3C"/>
+                </a:solidFill>
+                <a:latin typeface="Century Gothic Paneuropean"/>
+                <a:ea typeface="Century Gothic Paneuropean"/>
+                <a:cs typeface="Century Gothic Paneuropean"/>
+                <a:sym typeface="Century Gothic Paneuropean"/>
+              </a:rPr>
+              <a:t>Maître </a:t>
+            </a:r>
+            <a:r>
+              <a:rPr lang="en-US" sz="1000" u="none" strike="noStrike" spc="-3" dirty="0" err="1">
+                <a:solidFill>
+                  <a:srgbClr val="1D1E3C"/>
+                </a:solidFill>
+                <a:latin typeface="Century Gothic Paneuropean"/>
+                <a:ea typeface="Century Gothic Paneuropean"/>
+                <a:cs typeface="Century Gothic Paneuropean"/>
+                <a:sym typeface="Century Gothic Paneuropean"/>
+              </a:rPr>
+              <a:t>d’ouvrage</a:t>
+            </a:r>
+            <a:r>
+              <a:rPr lang="en-US" sz="1000" u="none" strike="noStrike" spc="-3" dirty="0">
+                <a:solidFill>
+                  <a:srgbClr val="1D1E3C"/>
+                </a:solidFill>
+                <a:latin typeface="Century Gothic Paneuropean"/>
+                <a:ea typeface="Century Gothic Paneuropean"/>
+                <a:cs typeface="Century Gothic Paneuropean"/>
+                <a:sym typeface="Century Gothic Paneuropean"/>
+              </a:rPr>
+              <a:t>: {{REF_MOA}}</a:t>
+            </a:r>
+          </a:p>
+          <a:p>
+            <a:pPr marL="0" lvl="0" indent="0" algn="l">
+              <a:lnSpc>
+                <a:spcPts val="1120"/>
+              </a:lnSpc>
+              <a:spcBef>
+                <a:spcPct val="0"/>
+              </a:spcBef>
+            </a:pPr>
+            <a:r>
+              <a:rPr lang="en-US" sz="800" u="none" strike="noStrike" spc="-2" dirty="0" err="1">
+                <a:solidFill>
+                  <a:srgbClr val="1D1E3C"/>
+                </a:solidFill>
+                <a:latin typeface="Century Gothic Paneuropean"/>
+                <a:ea typeface="Century Gothic Paneuropean"/>
+                <a:cs typeface="Century Gothic Paneuropean"/>
+                <a:sym typeface="Century Gothic Paneuropean"/>
+              </a:rPr>
+              <a:t>Montant</a:t>
+            </a:r>
+            <a:r>
+              <a:rPr lang="en-US" sz="800" u="none" strike="noStrike" spc="-2" dirty="0">
+                <a:solidFill>
+                  <a:srgbClr val="1D1E3C"/>
+                </a:solidFill>
+                <a:latin typeface="Century Gothic Paneuropean"/>
+                <a:ea typeface="Century Gothic Paneuropean"/>
+                <a:cs typeface="Century Gothic Paneuropean"/>
+                <a:sym typeface="Century Gothic Paneuropean"/>
+              </a:rPr>
+              <a:t>: {{REF_MONTANT}}</a:t>
+            </a:r>
+          </a:p>
+          <a:p>
+            <a:pPr marL="0" lvl="0" indent="0" algn="l">
+              <a:lnSpc>
+                <a:spcPts val="1120"/>
+              </a:lnSpc>
+              <a:spcBef>
+                <a:spcPct val="0"/>
+              </a:spcBef>
+            </a:pPr>
+            <a:r>
+              <a:rPr lang="en-US" sz="800" u="none" strike="noStrike" spc="-2" dirty="0">
+                <a:solidFill>
+                  <a:srgbClr val="1D1E3C"/>
+                </a:solidFill>
+                <a:latin typeface="Century Gothic Paneuropean"/>
+                <a:ea typeface="Century Gothic Paneuropean"/>
+                <a:cs typeface="Century Gothic Paneuropean"/>
+                <a:sym typeface="Century Gothic Paneuropean"/>
+              </a:rPr>
+              <a:t>Type de travaux </a:t>
+            </a:r>
+            <a:r>
+              <a:rPr lang="en-US" sz="800" u="none" strike="noStrike" spc="-2" dirty="0" err="1">
+                <a:solidFill>
+                  <a:srgbClr val="1D1E3C"/>
+                </a:solidFill>
+                <a:latin typeface="Century Gothic Paneuropean"/>
+                <a:ea typeface="Century Gothic Paneuropean"/>
+                <a:cs typeface="Century Gothic Paneuropean"/>
+                <a:sym typeface="Century Gothic Paneuropean"/>
+              </a:rPr>
+              <a:t>effectués</a:t>
+            </a:r>
+            <a:r>
+              <a:rPr lang="en-US" sz="800" u="none" strike="noStrike" spc="-2" dirty="0">
+                <a:solidFill>
+                  <a:srgbClr val="1D1E3C"/>
+                </a:solidFill>
+                <a:latin typeface="Century Gothic Paneuropean"/>
+                <a:ea typeface="Century Gothic Paneuropean"/>
+                <a:cs typeface="Century Gothic Paneuropean"/>
+                <a:sym typeface="Century Gothic Paneuropean"/>
+              </a:rPr>
+              <a:t>: {{REF_TRAVAUX}} </a:t>
+            </a:r>
+            <a:r>
+              <a:rPr lang="en-US" sz="800" u="none" strike="noStrike" spc="-2" dirty="0" err="1">
+                <a:solidFill>
+                  <a:srgbClr val="1D1E3C"/>
+                </a:solidFill>
+                <a:latin typeface="Century Gothic Paneuropean"/>
+                <a:ea typeface="Century Gothic Paneuropean"/>
+                <a:cs typeface="Century Gothic Paneuropean"/>
+                <a:sym typeface="Century Gothic Paneuropean"/>
+              </a:rPr>
+              <a:t>Réalisation</a:t>
+            </a:r>
+            <a:r>
+              <a:rPr lang="en-US" sz="800" b="1" u="none" strike="noStrike" spc="-2" dirty="0">
+                <a:solidFill>
+                  <a:srgbClr val="1D1E3C"/>
+                </a:solidFill>
+                <a:latin typeface="Century Gothic Paneuropean Bold"/>
+                <a:ea typeface="Century Gothic Paneuropean Bold"/>
+                <a:cs typeface="Century Gothic Paneuropean Bold"/>
+                <a:sym typeface="Century Gothic Paneuropean Bold"/>
+              </a:rPr>
+              <a:t>:  {{REF_REALISATION}}</a:t>
+            </a:r>
+          </a:p>
+          <a:p>
+            <a:pPr marL="0" lvl="0" indent="0" algn="l">
+              <a:lnSpc>
+                <a:spcPts val="1120"/>
+              </a:lnSpc>
+              <a:spcBef>
+                <a:spcPct val="0"/>
+              </a:spcBef>
+            </a:pPr>
+            <a:endParaRPr lang="en-US" sz="800" b="1" u="none" strike="noStrike" spc="-2" dirty="0">
+              <a:solidFill>
+                <a:srgbClr val="1D1E3C"/>
+              </a:solidFill>
+              <a:latin typeface="Century Gothic Paneuropean Bold"/>
+              <a:ea typeface="Century Gothic Paneuropean Bold"/>
+              <a:cs typeface="Century Gothic Paneuropean Bold"/>
+              <a:sym typeface="Century Gothic Paneuropean Bold"/>
+            </a:endParaRPr>
+          </a:p>
+        </p:txBody>
+      </p:sp>
+      <p:sp>
+        <p:nvSpPr>
+          <p:cNvPr id="49" name="reference_2">
+            <a:extLst>
+              <a:ext uri="{FF2B5EF4-FFF2-40B4-BE49-F238E27FC236}">
+                <a16:creationId xmlns:a16="http://schemas.microsoft.com/office/drawing/2014/main" id="{43DE34AC-3332-B54F-A71B-8E2FAA645E3D}"/>
+              </a:ext>
+            </a:extLst>
+          </p:cNvPr>
+          <p:cNvSpPr txBox="1"/>
+          <p:nvPr/>
+        </p:nvSpPr>
+        <p:spPr>
+          <a:xfrm>
+            <a:off x="5229319" y="6794500"/>
+            <a:ext cx="2200697" cy="914481"/>
+          </a:xfrm>
+          <a:prstGeom prst="rect">
+            <a:avLst/>
+          </a:prstGeom>
+        </p:spPr>
+        <p:txBody>
+          <a:bodyPr wrap="square" lIns="0" tIns="0" rIns="0" bIns="0" rtlCol="0" anchor="t">
+            <a:spAutoFit/>
+          </a:bodyPr>
+          <a:lstStyle/>
+          <a:p>
+            <a:pPr algn="l">
+              <a:lnSpc>
+                <a:spcPts val="1400"/>
+              </a:lnSpc>
+            </a:pPr>
+            <a:r>
+              <a:rPr lang="en-US" sz="1000" b="1" spc="-3" dirty="0">
+                <a:solidFill>
+                  <a:srgbClr val="1D1E3C"/>
+                </a:solidFill>
+                <a:latin typeface="Century Gothic Paneuropean Bold"/>
+                <a:ea typeface="Century Gothic Paneuropean Bold"/>
+                <a:cs typeface="Century Gothic Paneuropean Bold"/>
+                <a:sym typeface="Century Gothic Paneuropean Bold"/>
+              </a:rPr>
+              <a:t>{{REF_RESIDENCE}}</a:t>
+            </a:r>
+          </a:p>
+          <a:p>
+            <a:pPr marL="0" lvl="0" indent="0" algn="l">
+              <a:lnSpc>
+                <a:spcPts val="1400"/>
+              </a:lnSpc>
+              <a:spcBef>
+                <a:spcPct val="0"/>
+              </a:spcBef>
+            </a:pPr>
+            <a:r>
+              <a:rPr lang="en-US" sz="1000" u="none" strike="noStrike" spc="-3" dirty="0">
+                <a:solidFill>
+                  <a:srgbClr val="1D1E3C"/>
+                </a:solidFill>
+                <a:latin typeface="Century Gothic Paneuropean"/>
+                <a:ea typeface="Century Gothic Paneuropean"/>
+                <a:cs typeface="Century Gothic Paneuropean"/>
+                <a:sym typeface="Century Gothic Paneuropean"/>
+              </a:rPr>
+              <a:t>Maître </a:t>
+            </a:r>
+            <a:r>
+              <a:rPr lang="en-US" sz="1000" u="none" strike="noStrike" spc="-3" dirty="0" err="1">
+                <a:solidFill>
+                  <a:srgbClr val="1D1E3C"/>
+                </a:solidFill>
+                <a:latin typeface="Century Gothic Paneuropean"/>
+                <a:ea typeface="Century Gothic Paneuropean"/>
+                <a:cs typeface="Century Gothic Paneuropean"/>
+                <a:sym typeface="Century Gothic Paneuropean"/>
+              </a:rPr>
+              <a:t>d’ouvrage</a:t>
+            </a:r>
+            <a:r>
+              <a:rPr lang="en-US" sz="1000" u="none" strike="noStrike" spc="-3" dirty="0">
+                <a:solidFill>
+                  <a:srgbClr val="1D1E3C"/>
+                </a:solidFill>
+                <a:latin typeface="Century Gothic Paneuropean"/>
+                <a:ea typeface="Century Gothic Paneuropean"/>
+                <a:cs typeface="Century Gothic Paneuropean"/>
+                <a:sym typeface="Century Gothic Paneuropean"/>
+              </a:rPr>
+              <a:t>: {{REF_MOA}}</a:t>
+            </a:r>
+          </a:p>
+          <a:p>
+            <a:pPr marL="0" lvl="0" indent="0" algn="l">
+              <a:lnSpc>
+                <a:spcPts val="1120"/>
+              </a:lnSpc>
+              <a:spcBef>
+                <a:spcPct val="0"/>
+              </a:spcBef>
+            </a:pPr>
+            <a:r>
+              <a:rPr lang="en-US" sz="800" u="none" strike="noStrike" spc="-2" dirty="0" err="1">
+                <a:solidFill>
+                  <a:srgbClr val="1D1E3C"/>
+                </a:solidFill>
+                <a:latin typeface="Century Gothic Paneuropean"/>
+                <a:ea typeface="Century Gothic Paneuropean"/>
+                <a:cs typeface="Century Gothic Paneuropean"/>
+                <a:sym typeface="Century Gothic Paneuropean"/>
+              </a:rPr>
+              <a:t>Montant</a:t>
+            </a:r>
+            <a:r>
+              <a:rPr lang="en-US" sz="800" u="none" strike="noStrike" spc="-2" dirty="0">
+                <a:solidFill>
+                  <a:srgbClr val="1D1E3C"/>
+                </a:solidFill>
+                <a:latin typeface="Century Gothic Paneuropean"/>
+                <a:ea typeface="Century Gothic Paneuropean"/>
+                <a:cs typeface="Century Gothic Paneuropean"/>
+                <a:sym typeface="Century Gothic Paneuropean"/>
+              </a:rPr>
+              <a:t>: {{REF_MONTANT}}</a:t>
+            </a:r>
+          </a:p>
+          <a:p>
+            <a:pPr marL="0" lvl="0" indent="0" algn="l">
+              <a:lnSpc>
+                <a:spcPts val="1120"/>
+              </a:lnSpc>
+              <a:spcBef>
+                <a:spcPct val="0"/>
+              </a:spcBef>
+            </a:pPr>
+            <a:r>
+              <a:rPr lang="en-US" sz="800" u="none" strike="noStrike" spc="-2" dirty="0">
+                <a:solidFill>
+                  <a:srgbClr val="1D1E3C"/>
+                </a:solidFill>
+                <a:latin typeface="Century Gothic Paneuropean"/>
+                <a:ea typeface="Century Gothic Paneuropean"/>
+                <a:cs typeface="Century Gothic Paneuropean"/>
+                <a:sym typeface="Century Gothic Paneuropean"/>
+              </a:rPr>
+              <a:t>Type de travaux </a:t>
+            </a:r>
+            <a:r>
+              <a:rPr lang="en-US" sz="800" u="none" strike="noStrike" spc="-2" dirty="0" err="1">
+                <a:solidFill>
+                  <a:srgbClr val="1D1E3C"/>
+                </a:solidFill>
+                <a:latin typeface="Century Gothic Paneuropean"/>
+                <a:ea typeface="Century Gothic Paneuropean"/>
+                <a:cs typeface="Century Gothic Paneuropean"/>
+                <a:sym typeface="Century Gothic Paneuropean"/>
+              </a:rPr>
+              <a:t>effectués</a:t>
+            </a:r>
+            <a:r>
+              <a:rPr lang="en-US" sz="800" u="none" strike="noStrike" spc="-2" dirty="0">
+                <a:solidFill>
+                  <a:srgbClr val="1D1E3C"/>
+                </a:solidFill>
+                <a:latin typeface="Century Gothic Paneuropean"/>
+                <a:ea typeface="Century Gothic Paneuropean"/>
+                <a:cs typeface="Century Gothic Paneuropean"/>
+                <a:sym typeface="Century Gothic Paneuropean"/>
+              </a:rPr>
+              <a:t>: {{REF_TRAVAUX}} {</a:t>
+            </a:r>
+          </a:p>
+          <a:p>
+            <a:pPr marL="0" lvl="0" indent="0" algn="l">
+              <a:lnSpc>
+                <a:spcPts val="1120"/>
+              </a:lnSpc>
+              <a:spcBef>
+                <a:spcPct val="0"/>
+              </a:spcBef>
+            </a:pPr>
+            <a:r>
+              <a:rPr lang="en-US" sz="800" u="none" strike="noStrike" spc="-2" dirty="0" err="1">
+                <a:solidFill>
+                  <a:srgbClr val="1D1E3C"/>
+                </a:solidFill>
+                <a:latin typeface="Century Gothic Paneuropean"/>
+                <a:ea typeface="Century Gothic Paneuropean"/>
+                <a:cs typeface="Century Gothic Paneuropean"/>
+                <a:sym typeface="Century Gothic Paneuropean"/>
+              </a:rPr>
+              <a:t>Réalisation</a:t>
+            </a:r>
+            <a:r>
+              <a:rPr lang="en-US" sz="800" b="1" u="none" strike="noStrike" spc="-2" dirty="0">
+                <a:solidFill>
+                  <a:srgbClr val="1D1E3C"/>
+                </a:solidFill>
+                <a:latin typeface="Century Gothic Paneuropean Bold"/>
+                <a:ea typeface="Century Gothic Paneuropean Bold"/>
+                <a:cs typeface="Century Gothic Paneuropean Bold"/>
+                <a:sym typeface="Century Gothic Paneuropean Bold"/>
+              </a:rPr>
+              <a:t>:  {{REF_REALISATION}}</a:t>
+            </a:r>
+          </a:p>
+          <a:p>
+            <a:pPr marL="0" lvl="0" indent="0" algn="l">
+              <a:lnSpc>
+                <a:spcPts val="1120"/>
+              </a:lnSpc>
+              <a:spcBef>
+                <a:spcPct val="0"/>
+              </a:spcBef>
+            </a:pPr>
+            <a:endParaRPr lang="en-US" sz="800" b="1" u="none" strike="noStrike" spc="-2" dirty="0">
+              <a:solidFill>
+                <a:srgbClr val="1D1E3C"/>
+              </a:solidFill>
+              <a:latin typeface="Century Gothic Paneuropean Bold"/>
+              <a:ea typeface="Century Gothic Paneuropean Bold"/>
+              <a:cs typeface="Century Gothic Paneuropean Bold"/>
+              <a:sym typeface="Century Gothic Paneuropean Bold"/>
+            </a:endParaRPr>
+          </a:p>
+        </p:txBody>
+      </p:sp>
+      <p:sp>
+        <p:nvSpPr>
+          <p:cNvPr id="50" name="reference_3">
+            <a:extLst>
+              <a:ext uri="{FF2B5EF4-FFF2-40B4-BE49-F238E27FC236}">
+                <a16:creationId xmlns:a16="http://schemas.microsoft.com/office/drawing/2014/main" id="{0AE5D4CE-826C-0680-DBB2-9F05A6D52A19}"/>
+              </a:ext>
+            </a:extLst>
+          </p:cNvPr>
+          <p:cNvSpPr txBox="1"/>
+          <p:nvPr/>
+        </p:nvSpPr>
+        <p:spPr>
+          <a:xfrm>
+            <a:off x="3272958" y="7937419"/>
+            <a:ext cx="2200697" cy="914481"/>
+          </a:xfrm>
+          <a:prstGeom prst="rect">
+            <a:avLst/>
+          </a:prstGeom>
+        </p:spPr>
+        <p:txBody>
+          <a:bodyPr wrap="square" lIns="0" tIns="0" rIns="0" bIns="0" rtlCol="0" anchor="t">
+            <a:spAutoFit/>
+          </a:bodyPr>
+          <a:lstStyle/>
+          <a:p>
+            <a:pPr algn="l">
+              <a:lnSpc>
+                <a:spcPts val="1400"/>
+              </a:lnSpc>
+            </a:pPr>
+            <a:r>
+              <a:rPr lang="en-US" sz="1000" b="1" spc="-3" dirty="0">
+                <a:solidFill>
+                  <a:srgbClr val="1D1E3C"/>
+                </a:solidFill>
+                <a:latin typeface="Century Gothic Paneuropean Bold"/>
+                <a:ea typeface="Century Gothic Paneuropean Bold"/>
+                <a:cs typeface="Century Gothic Paneuropean Bold"/>
+                <a:sym typeface="Century Gothic Paneuropean Bold"/>
+              </a:rPr>
+              <a:t>{{REF_RESIDENCE}}</a:t>
+            </a:r>
+          </a:p>
+          <a:p>
+            <a:pPr marL="0" lvl="0" indent="0" algn="l">
+              <a:lnSpc>
+                <a:spcPts val="1400"/>
+              </a:lnSpc>
+              <a:spcBef>
+                <a:spcPct val="0"/>
+              </a:spcBef>
+            </a:pPr>
+            <a:r>
+              <a:rPr lang="en-US" sz="1000" u="none" strike="noStrike" spc="-3" dirty="0">
+                <a:solidFill>
+                  <a:srgbClr val="1D1E3C"/>
+                </a:solidFill>
+                <a:latin typeface="Century Gothic Paneuropean"/>
+                <a:ea typeface="Century Gothic Paneuropean"/>
+                <a:cs typeface="Century Gothic Paneuropean"/>
+                <a:sym typeface="Century Gothic Paneuropean"/>
+              </a:rPr>
+              <a:t>Maître </a:t>
+            </a:r>
+            <a:r>
+              <a:rPr lang="en-US" sz="1000" u="none" strike="noStrike" spc="-3" dirty="0" err="1">
+                <a:solidFill>
+                  <a:srgbClr val="1D1E3C"/>
+                </a:solidFill>
+                <a:latin typeface="Century Gothic Paneuropean"/>
+                <a:ea typeface="Century Gothic Paneuropean"/>
+                <a:cs typeface="Century Gothic Paneuropean"/>
+                <a:sym typeface="Century Gothic Paneuropean"/>
+              </a:rPr>
+              <a:t>d’ouvrage</a:t>
+            </a:r>
+            <a:r>
+              <a:rPr lang="en-US" sz="1000" u="none" strike="noStrike" spc="-3" dirty="0">
+                <a:solidFill>
+                  <a:srgbClr val="1D1E3C"/>
+                </a:solidFill>
+                <a:latin typeface="Century Gothic Paneuropean"/>
+                <a:ea typeface="Century Gothic Paneuropean"/>
+                <a:cs typeface="Century Gothic Paneuropean"/>
+                <a:sym typeface="Century Gothic Paneuropean"/>
+              </a:rPr>
+              <a:t>: {{REF_MOA}}</a:t>
+            </a:r>
+          </a:p>
+          <a:p>
+            <a:pPr marL="0" lvl="0" indent="0" algn="l">
+              <a:lnSpc>
+                <a:spcPts val="1120"/>
+              </a:lnSpc>
+              <a:spcBef>
+                <a:spcPct val="0"/>
+              </a:spcBef>
+            </a:pPr>
+            <a:r>
+              <a:rPr lang="en-US" sz="800" u="none" strike="noStrike" spc="-2" dirty="0" err="1">
+                <a:solidFill>
+                  <a:srgbClr val="1D1E3C"/>
+                </a:solidFill>
+                <a:latin typeface="Century Gothic Paneuropean"/>
+                <a:ea typeface="Century Gothic Paneuropean"/>
+                <a:cs typeface="Century Gothic Paneuropean"/>
+                <a:sym typeface="Century Gothic Paneuropean"/>
+              </a:rPr>
+              <a:t>Montant</a:t>
+            </a:r>
+            <a:r>
+              <a:rPr lang="en-US" sz="800" u="none" strike="noStrike" spc="-2" dirty="0">
+                <a:solidFill>
+                  <a:srgbClr val="1D1E3C"/>
+                </a:solidFill>
+                <a:latin typeface="Century Gothic Paneuropean"/>
+                <a:ea typeface="Century Gothic Paneuropean"/>
+                <a:cs typeface="Century Gothic Paneuropean"/>
+                <a:sym typeface="Century Gothic Paneuropean"/>
+              </a:rPr>
+              <a:t>: {{REF_MONTANT}}</a:t>
+            </a:r>
+          </a:p>
+          <a:p>
+            <a:pPr marL="0" lvl="0" indent="0" algn="l">
+              <a:lnSpc>
+                <a:spcPts val="1120"/>
+              </a:lnSpc>
+              <a:spcBef>
+                <a:spcPct val="0"/>
+              </a:spcBef>
+            </a:pPr>
+            <a:r>
+              <a:rPr lang="en-US" sz="800" u="none" strike="noStrike" spc="-2" dirty="0">
+                <a:solidFill>
+                  <a:srgbClr val="1D1E3C"/>
+                </a:solidFill>
+                <a:latin typeface="Century Gothic Paneuropean"/>
+                <a:ea typeface="Century Gothic Paneuropean"/>
+                <a:cs typeface="Century Gothic Paneuropean"/>
+                <a:sym typeface="Century Gothic Paneuropean"/>
+              </a:rPr>
+              <a:t>Type de travaux </a:t>
+            </a:r>
+            <a:r>
+              <a:rPr lang="en-US" sz="800" u="none" strike="noStrike" spc="-2" dirty="0" err="1">
+                <a:solidFill>
+                  <a:srgbClr val="1D1E3C"/>
+                </a:solidFill>
+                <a:latin typeface="Century Gothic Paneuropean"/>
+                <a:ea typeface="Century Gothic Paneuropean"/>
+                <a:cs typeface="Century Gothic Paneuropean"/>
+                <a:sym typeface="Century Gothic Paneuropean"/>
+              </a:rPr>
+              <a:t>effectués</a:t>
+            </a:r>
+            <a:r>
+              <a:rPr lang="en-US" sz="800" u="none" strike="noStrike" spc="-2" dirty="0">
+                <a:solidFill>
+                  <a:srgbClr val="1D1E3C"/>
+                </a:solidFill>
+                <a:latin typeface="Century Gothic Paneuropean"/>
+                <a:ea typeface="Century Gothic Paneuropean"/>
+                <a:cs typeface="Century Gothic Paneuropean"/>
+                <a:sym typeface="Century Gothic Paneuropean"/>
+              </a:rPr>
+              <a:t>: {{REF_TRAVAUX}} </a:t>
+            </a:r>
+            <a:r>
+              <a:rPr lang="en-US" sz="800" u="none" strike="noStrike" spc="-2" dirty="0" err="1">
+                <a:solidFill>
+                  <a:srgbClr val="1D1E3C"/>
+                </a:solidFill>
+                <a:latin typeface="Century Gothic Paneuropean"/>
+                <a:ea typeface="Century Gothic Paneuropean"/>
+                <a:cs typeface="Century Gothic Paneuropean"/>
+                <a:sym typeface="Century Gothic Paneuropean"/>
+              </a:rPr>
+              <a:t>Réalisation</a:t>
+            </a:r>
+            <a:r>
+              <a:rPr lang="en-US" sz="800" b="1" u="none" strike="noStrike" spc="-2" dirty="0">
+                <a:solidFill>
+                  <a:srgbClr val="1D1E3C"/>
+                </a:solidFill>
+                <a:latin typeface="Century Gothic Paneuropean Bold"/>
+                <a:ea typeface="Century Gothic Paneuropean Bold"/>
+                <a:cs typeface="Century Gothic Paneuropean Bold"/>
+                <a:sym typeface="Century Gothic Paneuropean Bold"/>
+              </a:rPr>
+              <a:t>:  {{REF_REALISATION}}</a:t>
+            </a:r>
+          </a:p>
+          <a:p>
+            <a:pPr marL="0" lvl="0" indent="0" algn="l">
+              <a:lnSpc>
+                <a:spcPts val="1120"/>
+              </a:lnSpc>
+              <a:spcBef>
+                <a:spcPct val="0"/>
+              </a:spcBef>
+            </a:pPr>
+            <a:endParaRPr lang="en-US" sz="800" b="1" u="none" strike="noStrike" spc="-2" dirty="0">
+              <a:solidFill>
+                <a:srgbClr val="1D1E3C"/>
+              </a:solidFill>
+              <a:latin typeface="Century Gothic Paneuropean Bold"/>
+              <a:ea typeface="Century Gothic Paneuropean Bold"/>
+              <a:cs typeface="Century Gothic Paneuropean Bold"/>
+              <a:sym typeface="Century Gothic Paneuropean Bold"/>
+            </a:endParaRPr>
+          </a:p>
+        </p:txBody>
+      </p:sp>
+      <p:sp>
+        <p:nvSpPr>
+          <p:cNvPr id="51" name="reference_4">
+            <a:extLst>
+              <a:ext uri="{FF2B5EF4-FFF2-40B4-BE49-F238E27FC236}">
+                <a16:creationId xmlns:a16="http://schemas.microsoft.com/office/drawing/2014/main" id="{DD617036-6139-7ACA-1529-528E6290BF50}"/>
+              </a:ext>
+            </a:extLst>
+          </p:cNvPr>
+          <p:cNvSpPr txBox="1"/>
+          <p:nvPr/>
+        </p:nvSpPr>
+        <p:spPr>
+          <a:xfrm>
+            <a:off x="5229319" y="8851819"/>
+            <a:ext cx="2200697" cy="914481"/>
+          </a:xfrm>
+          <a:prstGeom prst="rect">
+            <a:avLst/>
+          </a:prstGeom>
+        </p:spPr>
+        <p:txBody>
+          <a:bodyPr wrap="square" lIns="0" tIns="0" rIns="0" bIns="0" rtlCol="0" anchor="t">
+            <a:spAutoFit/>
+          </a:bodyPr>
+          <a:lstStyle/>
+          <a:p>
+            <a:pPr algn="l">
+              <a:lnSpc>
+                <a:spcPts val="1400"/>
+              </a:lnSpc>
+            </a:pPr>
+            <a:r>
+              <a:rPr lang="en-US" sz="1000" b="1" spc="-3" dirty="0">
+                <a:solidFill>
+                  <a:srgbClr val="1D1E3C"/>
+                </a:solidFill>
+                <a:latin typeface="Century Gothic Paneuropean Bold"/>
+                <a:ea typeface="Century Gothic Paneuropean Bold"/>
+                <a:cs typeface="Century Gothic Paneuropean Bold"/>
+                <a:sym typeface="Century Gothic Paneuropean Bold"/>
+              </a:rPr>
+              <a:t>{{REF_RESIDENCE}}</a:t>
+            </a:r>
+          </a:p>
+          <a:p>
+            <a:pPr marL="0" lvl="0" indent="0" algn="l">
+              <a:lnSpc>
+                <a:spcPts val="1400"/>
+              </a:lnSpc>
+              <a:spcBef>
+                <a:spcPct val="0"/>
+              </a:spcBef>
+            </a:pPr>
+            <a:r>
+              <a:rPr lang="en-US" sz="1000" u="none" strike="noStrike" spc="-3" dirty="0">
+                <a:solidFill>
+                  <a:srgbClr val="1D1E3C"/>
+                </a:solidFill>
+                <a:latin typeface="Century Gothic Paneuropean"/>
+                <a:ea typeface="Century Gothic Paneuropean"/>
+                <a:cs typeface="Century Gothic Paneuropean"/>
+                <a:sym typeface="Century Gothic Paneuropean"/>
+              </a:rPr>
+              <a:t>Maître </a:t>
+            </a:r>
+            <a:r>
+              <a:rPr lang="en-US" sz="1000" u="none" strike="noStrike" spc="-3" dirty="0" err="1">
+                <a:solidFill>
+                  <a:srgbClr val="1D1E3C"/>
+                </a:solidFill>
+                <a:latin typeface="Century Gothic Paneuropean"/>
+                <a:ea typeface="Century Gothic Paneuropean"/>
+                <a:cs typeface="Century Gothic Paneuropean"/>
+                <a:sym typeface="Century Gothic Paneuropean"/>
+              </a:rPr>
+              <a:t>d’ouvrage</a:t>
+            </a:r>
+            <a:r>
+              <a:rPr lang="en-US" sz="1000" u="none" strike="noStrike" spc="-3" dirty="0">
+                <a:solidFill>
+                  <a:srgbClr val="1D1E3C"/>
+                </a:solidFill>
+                <a:latin typeface="Century Gothic Paneuropean"/>
+                <a:ea typeface="Century Gothic Paneuropean"/>
+                <a:cs typeface="Century Gothic Paneuropean"/>
+                <a:sym typeface="Century Gothic Paneuropean"/>
+              </a:rPr>
+              <a:t>: {{REF_MOA}}</a:t>
+            </a:r>
+          </a:p>
+          <a:p>
+            <a:pPr marL="0" lvl="0" indent="0" algn="l">
+              <a:lnSpc>
+                <a:spcPts val="1120"/>
+              </a:lnSpc>
+              <a:spcBef>
+                <a:spcPct val="0"/>
+              </a:spcBef>
+            </a:pPr>
+            <a:r>
+              <a:rPr lang="en-US" sz="800" u="none" strike="noStrike" spc="-2" dirty="0" err="1">
+                <a:solidFill>
+                  <a:srgbClr val="1D1E3C"/>
+                </a:solidFill>
+                <a:latin typeface="Century Gothic Paneuropean"/>
+                <a:ea typeface="Century Gothic Paneuropean"/>
+                <a:cs typeface="Century Gothic Paneuropean"/>
+                <a:sym typeface="Century Gothic Paneuropean"/>
+              </a:rPr>
+              <a:t>Montant</a:t>
+            </a:r>
+            <a:r>
+              <a:rPr lang="en-US" sz="800" u="none" strike="noStrike" spc="-2" dirty="0">
+                <a:solidFill>
+                  <a:srgbClr val="1D1E3C"/>
+                </a:solidFill>
+                <a:latin typeface="Century Gothic Paneuropean"/>
+                <a:ea typeface="Century Gothic Paneuropean"/>
+                <a:cs typeface="Century Gothic Paneuropean"/>
+                <a:sym typeface="Century Gothic Paneuropean"/>
+              </a:rPr>
+              <a:t>: {{REF_MONTANT}}</a:t>
+            </a:r>
+          </a:p>
+          <a:p>
+            <a:pPr marL="0" lvl="0" indent="0" algn="l">
+              <a:lnSpc>
+                <a:spcPts val="1120"/>
+              </a:lnSpc>
+              <a:spcBef>
+                <a:spcPct val="0"/>
+              </a:spcBef>
+            </a:pPr>
+            <a:r>
+              <a:rPr lang="en-US" sz="800" u="none" strike="noStrike" spc="-2" dirty="0">
+                <a:solidFill>
+                  <a:srgbClr val="1D1E3C"/>
+                </a:solidFill>
+                <a:latin typeface="Century Gothic Paneuropean"/>
+                <a:ea typeface="Century Gothic Paneuropean"/>
+                <a:cs typeface="Century Gothic Paneuropean"/>
+                <a:sym typeface="Century Gothic Paneuropean"/>
+              </a:rPr>
+              <a:t>Type de travaux </a:t>
+            </a:r>
+            <a:r>
+              <a:rPr lang="en-US" sz="800" u="none" strike="noStrike" spc="-2" dirty="0" err="1">
+                <a:solidFill>
+                  <a:srgbClr val="1D1E3C"/>
+                </a:solidFill>
+                <a:latin typeface="Century Gothic Paneuropean"/>
+                <a:ea typeface="Century Gothic Paneuropean"/>
+                <a:cs typeface="Century Gothic Paneuropean"/>
+                <a:sym typeface="Century Gothic Paneuropean"/>
+              </a:rPr>
+              <a:t>effectués</a:t>
+            </a:r>
+            <a:r>
+              <a:rPr lang="en-US" sz="800" u="none" strike="noStrike" spc="-2" dirty="0">
+                <a:solidFill>
+                  <a:srgbClr val="1D1E3C"/>
+                </a:solidFill>
+                <a:latin typeface="Century Gothic Paneuropean"/>
+                <a:ea typeface="Century Gothic Paneuropean"/>
+                <a:cs typeface="Century Gothic Paneuropean"/>
+                <a:sym typeface="Century Gothic Paneuropean"/>
+              </a:rPr>
+              <a:t>: {{REF_TRAVAUX}} </a:t>
+            </a:r>
+            <a:r>
+              <a:rPr lang="en-US" sz="800" u="none" strike="noStrike" spc="-2" dirty="0" err="1">
+                <a:solidFill>
+                  <a:srgbClr val="1D1E3C"/>
+                </a:solidFill>
+                <a:latin typeface="Century Gothic Paneuropean"/>
+                <a:ea typeface="Century Gothic Paneuropean"/>
+                <a:cs typeface="Century Gothic Paneuropean"/>
+                <a:sym typeface="Century Gothic Paneuropean"/>
+              </a:rPr>
+              <a:t>Réalisation</a:t>
+            </a:r>
+            <a:r>
+              <a:rPr lang="en-US" sz="800" b="1" u="none" strike="noStrike" spc="-2" dirty="0">
+                <a:solidFill>
+                  <a:srgbClr val="1D1E3C"/>
+                </a:solidFill>
+                <a:latin typeface="Century Gothic Paneuropean Bold"/>
+                <a:ea typeface="Century Gothic Paneuropean Bold"/>
+                <a:cs typeface="Century Gothic Paneuropean Bold"/>
+                <a:sym typeface="Century Gothic Paneuropean Bold"/>
+              </a:rPr>
+              <a:t>:  {{REF_REALISATION}}</a:t>
+            </a:r>
+          </a:p>
+          <a:p>
+            <a:pPr marL="0" lvl="0" indent="0" algn="l">
+              <a:lnSpc>
+                <a:spcPts val="1120"/>
+              </a:lnSpc>
+              <a:spcBef>
+                <a:spcPct val="0"/>
+              </a:spcBef>
+            </a:pPr>
+            <a:endParaRPr lang="en-US" sz="800" b="1" u="none" strike="noStrike" spc="-2" dirty="0">
+              <a:solidFill>
+                <a:srgbClr val="1D1E3C"/>
+              </a:solidFill>
+              <a:latin typeface="Century Gothic Paneuropean Bold"/>
+              <a:ea typeface="Century Gothic Paneuropean Bold"/>
+              <a:cs typeface="Century Gothic Paneuropean Bold"/>
+              <a:sym typeface="Century Gothic Paneuropean Bold"/>
+            </a:endParaRPr>
+          </a:p>
+        </p:txBody>
+      </p:sp>
+      <p:sp>
+        <p:nvSpPr>
+          <p:cNvPr id="52" name="reference_5">
+            <a:extLst>
+              <a:ext uri="{FF2B5EF4-FFF2-40B4-BE49-F238E27FC236}">
+                <a16:creationId xmlns:a16="http://schemas.microsoft.com/office/drawing/2014/main" id="{E0C1F2E6-907E-4170-C820-D34DFAEDBD2F}"/>
+              </a:ext>
+            </a:extLst>
+          </p:cNvPr>
+          <p:cNvSpPr txBox="1"/>
+          <p:nvPr/>
+        </p:nvSpPr>
+        <p:spPr>
+          <a:xfrm>
+            <a:off x="3307406" y="9766219"/>
+            <a:ext cx="2200697" cy="914481"/>
+          </a:xfrm>
+          <a:prstGeom prst="rect">
+            <a:avLst/>
+          </a:prstGeom>
+        </p:spPr>
+        <p:txBody>
+          <a:bodyPr wrap="square" lIns="0" tIns="0" rIns="0" bIns="0" rtlCol="0" anchor="t">
+            <a:spAutoFit/>
+          </a:bodyPr>
+          <a:lstStyle/>
+          <a:p>
+            <a:pPr algn="l">
+              <a:lnSpc>
+                <a:spcPts val="1400"/>
+              </a:lnSpc>
+            </a:pPr>
+            <a:r>
+              <a:rPr lang="en-US" sz="1000" b="1" spc="-3" dirty="0">
+                <a:solidFill>
+                  <a:srgbClr val="1D1E3C"/>
+                </a:solidFill>
+                <a:latin typeface="Century Gothic Paneuropean Bold"/>
+                <a:ea typeface="Century Gothic Paneuropean Bold"/>
+                <a:cs typeface="Century Gothic Paneuropean Bold"/>
+                <a:sym typeface="Century Gothic Paneuropean Bold"/>
+              </a:rPr>
+              <a:t>{{REF_RESIDENCE}}</a:t>
+            </a:r>
+          </a:p>
+          <a:p>
+            <a:pPr marL="0" lvl="0" indent="0" algn="l">
+              <a:lnSpc>
+                <a:spcPts val="1400"/>
+              </a:lnSpc>
+              <a:spcBef>
+                <a:spcPct val="0"/>
+              </a:spcBef>
+            </a:pPr>
+            <a:r>
+              <a:rPr lang="en-US" sz="1000" u="none" strike="noStrike" spc="-3" dirty="0">
+                <a:solidFill>
+                  <a:srgbClr val="1D1E3C"/>
+                </a:solidFill>
+                <a:latin typeface="Century Gothic Paneuropean"/>
+                <a:ea typeface="Century Gothic Paneuropean"/>
+                <a:cs typeface="Century Gothic Paneuropean"/>
+                <a:sym typeface="Century Gothic Paneuropean"/>
+              </a:rPr>
+              <a:t>Maître </a:t>
+            </a:r>
+            <a:r>
+              <a:rPr lang="en-US" sz="1000" u="none" strike="noStrike" spc="-3" dirty="0" err="1">
+                <a:solidFill>
+                  <a:srgbClr val="1D1E3C"/>
+                </a:solidFill>
+                <a:latin typeface="Century Gothic Paneuropean"/>
+                <a:ea typeface="Century Gothic Paneuropean"/>
+                <a:cs typeface="Century Gothic Paneuropean"/>
+                <a:sym typeface="Century Gothic Paneuropean"/>
+              </a:rPr>
+              <a:t>d’ouvrage</a:t>
+            </a:r>
+            <a:r>
+              <a:rPr lang="en-US" sz="1000" u="none" strike="noStrike" spc="-3" dirty="0">
+                <a:solidFill>
+                  <a:srgbClr val="1D1E3C"/>
+                </a:solidFill>
+                <a:latin typeface="Century Gothic Paneuropean"/>
+                <a:ea typeface="Century Gothic Paneuropean"/>
+                <a:cs typeface="Century Gothic Paneuropean"/>
+                <a:sym typeface="Century Gothic Paneuropean"/>
+              </a:rPr>
+              <a:t>: {{REF_MOA}}</a:t>
+            </a:r>
+          </a:p>
+          <a:p>
+            <a:pPr marL="0" lvl="0" indent="0" algn="l">
+              <a:lnSpc>
+                <a:spcPts val="1120"/>
+              </a:lnSpc>
+              <a:spcBef>
+                <a:spcPct val="0"/>
+              </a:spcBef>
+            </a:pPr>
+            <a:r>
+              <a:rPr lang="en-US" sz="800" u="none" strike="noStrike" spc="-2" dirty="0" err="1">
+                <a:solidFill>
+                  <a:srgbClr val="1D1E3C"/>
+                </a:solidFill>
+                <a:latin typeface="Century Gothic Paneuropean"/>
+                <a:ea typeface="Century Gothic Paneuropean"/>
+                <a:cs typeface="Century Gothic Paneuropean"/>
+                <a:sym typeface="Century Gothic Paneuropean"/>
+              </a:rPr>
+              <a:t>Montant</a:t>
+            </a:r>
+            <a:r>
+              <a:rPr lang="en-US" sz="800" u="none" strike="noStrike" spc="-2" dirty="0">
+                <a:solidFill>
+                  <a:srgbClr val="1D1E3C"/>
+                </a:solidFill>
+                <a:latin typeface="Century Gothic Paneuropean"/>
+                <a:ea typeface="Century Gothic Paneuropean"/>
+                <a:cs typeface="Century Gothic Paneuropean"/>
+                <a:sym typeface="Century Gothic Paneuropean"/>
+              </a:rPr>
+              <a:t>: {{REF_MONTANT}}</a:t>
+            </a:r>
+          </a:p>
+          <a:p>
+            <a:pPr marL="0" lvl="0" indent="0" algn="l">
+              <a:lnSpc>
+                <a:spcPts val="1120"/>
+              </a:lnSpc>
+              <a:spcBef>
+                <a:spcPct val="0"/>
+              </a:spcBef>
+            </a:pPr>
+            <a:r>
+              <a:rPr lang="en-US" sz="800" u="none" strike="noStrike" spc="-2" dirty="0">
+                <a:solidFill>
+                  <a:srgbClr val="1D1E3C"/>
+                </a:solidFill>
+                <a:latin typeface="Century Gothic Paneuropean"/>
+                <a:ea typeface="Century Gothic Paneuropean"/>
+                <a:cs typeface="Century Gothic Paneuropean"/>
+                <a:sym typeface="Century Gothic Paneuropean"/>
+              </a:rPr>
+              <a:t>Type de travaux </a:t>
+            </a:r>
+            <a:r>
+              <a:rPr lang="en-US" sz="800" u="none" strike="noStrike" spc="-2" dirty="0" err="1">
+                <a:solidFill>
+                  <a:srgbClr val="1D1E3C"/>
+                </a:solidFill>
+                <a:latin typeface="Century Gothic Paneuropean"/>
+                <a:ea typeface="Century Gothic Paneuropean"/>
+                <a:cs typeface="Century Gothic Paneuropean"/>
+                <a:sym typeface="Century Gothic Paneuropean"/>
+              </a:rPr>
+              <a:t>effectués</a:t>
+            </a:r>
+            <a:r>
+              <a:rPr lang="en-US" sz="800" u="none" strike="noStrike" spc="-2" dirty="0">
+                <a:solidFill>
+                  <a:srgbClr val="1D1E3C"/>
+                </a:solidFill>
+                <a:latin typeface="Century Gothic Paneuropean"/>
+                <a:ea typeface="Century Gothic Paneuropean"/>
+                <a:cs typeface="Century Gothic Paneuropean"/>
+                <a:sym typeface="Century Gothic Paneuropean"/>
+              </a:rPr>
+              <a:t>: {{REF_TRAVAUX}} </a:t>
+            </a:r>
+            <a:r>
+              <a:rPr lang="en-US" sz="800" u="none" strike="noStrike" spc="-2" dirty="0" err="1">
+                <a:solidFill>
+                  <a:srgbClr val="1D1E3C"/>
+                </a:solidFill>
+                <a:latin typeface="Century Gothic Paneuropean"/>
+                <a:ea typeface="Century Gothic Paneuropean"/>
+                <a:cs typeface="Century Gothic Paneuropean"/>
+                <a:sym typeface="Century Gothic Paneuropean"/>
+              </a:rPr>
+              <a:t>Réalisation</a:t>
+            </a:r>
+            <a:r>
+              <a:rPr lang="en-US" sz="800" b="1" u="none" strike="noStrike" spc="-2" dirty="0">
+                <a:solidFill>
+                  <a:srgbClr val="1D1E3C"/>
+                </a:solidFill>
+                <a:latin typeface="Century Gothic Paneuropean Bold"/>
+                <a:ea typeface="Century Gothic Paneuropean Bold"/>
+                <a:cs typeface="Century Gothic Paneuropean Bold"/>
+                <a:sym typeface="Century Gothic Paneuropean Bold"/>
+              </a:rPr>
+              <a:t>:  {{REF_REALISATION}}</a:t>
+            </a:r>
+          </a:p>
+          <a:p>
+            <a:pPr marL="0" lvl="0" indent="0" algn="l">
+              <a:lnSpc>
+                <a:spcPts val="1120"/>
+              </a:lnSpc>
+              <a:spcBef>
+                <a:spcPct val="0"/>
+              </a:spcBef>
+            </a:pPr>
+            <a:endParaRPr lang="en-US" sz="800" b="1" u="none" strike="noStrike" spc="-2" dirty="0">
+              <a:solidFill>
+                <a:srgbClr val="1D1E3C"/>
+              </a:solidFill>
+              <a:latin typeface="Century Gothic Paneuropean Bold"/>
+              <a:ea typeface="Century Gothic Paneuropean Bold"/>
+              <a:cs typeface="Century Gothic Paneuropean Bold"/>
+              <a:sym typeface="Century Gothic Paneuropean Bold"/>
+            </a:endParaRPr>
           </a:p>
         </p:txBody>
       </p:sp>

</xml_diff>